<commit_message>
preparar limpieza de env
</commit_message>
<xml_diff>
--- a/plantillas/FICHA_COMLED_MASTER.pptx
+++ b/plantillas/FICHA_COMLED_MASTER.pptx
@@ -823,7 +823,7 @@
         <p:spPr>
           <a:xfrm>
             <a:off x="722312" y="2906713"/>
-            <a:ext cx="7772401" cy="1500205"/>
+            <a:ext cx="7772401" cy="1500209"/>
           </a:xfrm>
           <a:prstGeom prst="rect">
             <a:avLst/>
@@ -1743,7 +1743,7 @@
         <p:spPr>
           <a:xfrm>
             <a:off x="1792288" y="5367337"/>
-            <a:ext cx="5486404" cy="804880"/>
+            <a:ext cx="5486404" cy="804884"/>
           </a:xfrm>
           <a:prstGeom prst="rect">
             <a:avLst/>
@@ -2814,8 +2814,8 @@
         </p:nvSpPr>
         <p:spPr>
           <a:xfrm flipV="1">
-            <a:off x="2496572" y="130612"/>
-            <a:ext cx="13" cy="686980"/>
+            <a:off x="2496572" y="130610"/>
+            <a:ext cx="13" cy="686985"/>
           </a:xfrm>
           <a:prstGeom prst="line">
             <a:avLst/>
@@ -2842,8 +2842,8 @@
         </p:nvSpPr>
         <p:spPr>
           <a:xfrm flipH="1" flipV="1">
-            <a:off x="2501329" y="924425"/>
-            <a:ext cx="4892872" cy="13"/>
+            <a:off x="2501326" y="924425"/>
+            <a:ext cx="4892877" cy="13"/>
           </a:xfrm>
           <a:prstGeom prst="line">
             <a:avLst/>
@@ -2871,7 +2871,7 @@
         <p:spPr>
           <a:xfrm>
             <a:off x="2467442" y="2313100"/>
-            <a:ext cx="680843" cy="657440"/>
+            <a:ext cx="680843" cy="657444"/>
           </a:xfrm>
           <a:custGeom>
             <a:avLst/>
@@ -2972,7 +2972,7 @@
         <p:spPr>
           <a:xfrm>
             <a:off x="3262114" y="2313100"/>
-            <a:ext cx="680851" cy="657440"/>
+            <a:ext cx="680855" cy="657444"/>
           </a:xfrm>
           <a:custGeom>
             <a:avLst/>
@@ -3073,7 +3073,7 @@
         <p:spPr>
           <a:xfrm>
             <a:off x="4056791" y="2313100"/>
-            <a:ext cx="680852" cy="657440"/>
+            <a:ext cx="680856" cy="657444"/>
           </a:xfrm>
           <a:custGeom>
             <a:avLst/>
@@ -3174,7 +3174,7 @@
         <p:spPr>
           <a:xfrm>
             <a:off x="4851925" y="2313100"/>
-            <a:ext cx="680852" cy="657440"/>
+            <a:ext cx="680856" cy="657444"/>
           </a:xfrm>
           <a:custGeom>
             <a:avLst/>
@@ -3332,7 +3332,7 @@
         <p:spPr>
           <a:xfrm>
             <a:off x="1023070" y="8830078"/>
-            <a:ext cx="430090" cy="307532"/>
+            <a:ext cx="430090" cy="307536"/>
           </a:xfrm>
           <a:prstGeom prst="rect">
             <a:avLst/>
@@ -3428,7 +3428,7 @@
         <p:spPr>
           <a:xfrm>
             <a:off x="6687566" y="1385681"/>
-            <a:ext cx="750237" cy="696776"/>
+            <a:ext cx="750241" cy="696776"/>
           </a:xfrm>
           <a:prstGeom prst="rect">
             <a:avLst/>
@@ -3460,7 +3460,7 @@
         <p:spPr>
           <a:xfrm>
             <a:off x="5966128" y="2069638"/>
-            <a:ext cx="1363256" cy="938931"/>
+            <a:ext cx="1363260" cy="938931"/>
           </a:xfrm>
           <a:prstGeom prst="rect">
             <a:avLst/>
@@ -3492,7 +3492,7 @@
         <p:spPr>
           <a:xfrm>
             <a:off x="5785155" y="1358590"/>
-            <a:ext cx="750029" cy="750967"/>
+            <a:ext cx="750033" cy="750971"/>
           </a:xfrm>
           <a:prstGeom prst="rect">
             <a:avLst/>
@@ -4198,7 +4198,7 @@
         <p:spPr>
           <a:xfrm>
             <a:off x="-2" y="10356001"/>
-            <a:ext cx="7560003" cy="319288"/>
+            <a:ext cx="7560003" cy="319292"/>
           </a:xfrm>
           <a:prstGeom prst="rect">
             <a:avLst/>
@@ -4230,7 +4230,7 @@
         <p:spPr>
           <a:xfrm>
             <a:off x="2836707" y="8571241"/>
-            <a:ext cx="2122191" cy="831791"/>
+            <a:ext cx="2122195" cy="831791"/>
           </a:xfrm>
           <a:prstGeom prst="rect">
             <a:avLst/>
@@ -4429,7 +4429,7 @@
         </p:nvSpPr>
         <p:spPr>
           <a:xfrm>
-            <a:off x="2783714" y="124639"/>
+            <a:off x="2783714" y="124635"/>
             <a:ext cx="4328099" cy="507461"/>
           </a:xfrm>
           <a:prstGeom prst="rect">
@@ -4526,7 +4526,7 @@
         <p:spPr>
           <a:xfrm>
             <a:off x="2517903" y="1023182"/>
-            <a:ext cx="2964409" cy="831791"/>
+            <a:ext cx="2964413" cy="1111191"/>
           </a:xfrm>
           <a:prstGeom prst="rect">
             <a:avLst/>
@@ -4613,6 +4613,32 @@
               </a:defRPr>
             </a:pPr>
           </a:p>
+          <a:p>
+            <a:pPr algn="just">
+              <a:lnSpc>
+                <a:spcPts val="1100"/>
+              </a:lnSpc>
+              <a:defRPr sz="800">
+                <a:latin typeface="Arial"/>
+                <a:ea typeface="Arial"/>
+                <a:cs typeface="Arial"/>
+                <a:sym typeface="Arial"/>
+              </a:defRPr>
+            </a:pPr>
+          </a:p>
+          <a:p>
+            <a:pPr algn="just">
+              <a:lnSpc>
+                <a:spcPts val="1100"/>
+              </a:lnSpc>
+              <a:defRPr sz="800">
+                <a:latin typeface="Arial"/>
+                <a:ea typeface="Arial"/>
+                <a:cs typeface="Arial"/>
+                <a:sym typeface="Arial"/>
+              </a:defRPr>
+            </a:pPr>
+          </a:p>
         </p:txBody>
       </p:sp>
       <p:sp>
@@ -4624,7 +4650,7 @@
         <p:spPr>
           <a:xfrm>
             <a:off x="2720344" y="2384125"/>
-            <a:ext cx="175041" cy="130600"/>
+            <a:ext cx="175045" cy="130600"/>
           </a:xfrm>
           <a:prstGeom prst="rect">
             <a:avLst/>
@@ -4768,7 +4794,7 @@
         <p:spPr>
           <a:xfrm>
             <a:off x="4924252" y="2384125"/>
-            <a:ext cx="536198" cy="130600"/>
+            <a:ext cx="536202" cy="130600"/>
           </a:xfrm>
           <a:prstGeom prst="rect">
             <a:avLst/>
@@ -4864,7 +4890,7 @@
         <p:spPr>
           <a:xfrm>
             <a:off x="3204577" y="2596925"/>
-            <a:ext cx="750238" cy="251039"/>
+            <a:ext cx="750242" cy="251039"/>
           </a:xfrm>
           <a:prstGeom prst="rect">
             <a:avLst/>
@@ -4911,8 +4937,8 @@
         </p:nvSpPr>
         <p:spPr>
           <a:xfrm>
-            <a:off x="4060940" y="2591671"/>
-            <a:ext cx="719401" cy="251039"/>
+            <a:off x="4060940" y="2553571"/>
+            <a:ext cx="719405" cy="517739"/>
           </a:xfrm>
           <a:prstGeom prst="rect">
             <a:avLst/>
@@ -4946,7 +4972,7 @@
           <a:p>
             <a:pPr/>
             <a:r>
-              <a:t>{{ip}}</a:t>
+              <a:t>{{ip_resumido}}</a:t>
             </a:r>
           </a:p>
         </p:txBody>
@@ -4960,7 +4986,7 @@
         <p:spPr>
           <a:xfrm>
             <a:off x="5099089" y="2529732"/>
-            <a:ext cx="158966" cy="251039"/>
+            <a:ext cx="158970" cy="251039"/>
           </a:xfrm>
           <a:prstGeom prst="rect">
             <a:avLst/>
@@ -5008,7 +5034,7 @@
         <p:spPr>
           <a:xfrm>
             <a:off x="5045385" y="2779210"/>
-            <a:ext cx="280970" cy="127001"/>
+            <a:ext cx="280974" cy="127001"/>
           </a:xfrm>
           <a:prstGeom prst="rect">
             <a:avLst/>
@@ -5152,7 +5178,7 @@
         <p:spPr>
           <a:xfrm>
             <a:off x="428473" y="3871438"/>
-            <a:ext cx="719394" cy="153611"/>
+            <a:ext cx="719394" cy="318711"/>
           </a:xfrm>
           <a:prstGeom prst="rect">
             <a:avLst/>
@@ -5186,7 +5212,7 @@
           <a:p>
             <a:pPr/>
             <a:r>
-              <a:t>{{potencia}}</a:t>
+              <a:t>{{potencia_resumido}}</a:t>
             </a:r>
           </a:p>
         </p:txBody>
@@ -5199,8 +5225,8 @@
         </p:nvSpPr>
         <p:spPr>
           <a:xfrm>
-            <a:off x="1065115" y="3894441"/>
-            <a:ext cx="1548472" cy="153611"/>
+            <a:off x="1065112" y="3869039"/>
+            <a:ext cx="1548478" cy="153611"/>
           </a:xfrm>
           <a:prstGeom prst="rect">
             <a:avLst/>
@@ -5234,7 +5260,7 @@
           <a:p>
             <a:pPr/>
             <a:r>
-              <a:t>{{flujo_luminoso}}</a:t>
+              <a:t>{{flujo_resumido}}</a:t>
             </a:r>
           </a:p>
         </p:txBody>
@@ -5247,8 +5273,8 @@
         </p:nvSpPr>
         <p:spPr>
           <a:xfrm>
-            <a:off x="2431029" y="3894439"/>
-            <a:ext cx="1489494" cy="153611"/>
+            <a:off x="2392926" y="3869039"/>
+            <a:ext cx="1489499" cy="153611"/>
           </a:xfrm>
           <a:prstGeom prst="rect">
             <a:avLst/>
@@ -5282,7 +5308,7 @@
           <a:p>
             <a:pPr/>
             <a:r>
-              <a:t>{{eficacia_luminosa}}</a:t>
+              <a:t>{{eficacia_resumido}}</a:t>
             </a:r>
           </a:p>
         </p:txBody>
@@ -5295,7 +5321,7 @@
         </p:nvSpPr>
         <p:spPr>
           <a:xfrm>
-            <a:off x="3565280" y="3885403"/>
+            <a:off x="3527180" y="3860003"/>
             <a:ext cx="1710716" cy="153611"/>
           </a:xfrm>
           <a:prstGeom prst="rect">
@@ -5330,7 +5356,7 @@
           <a:p>
             <a:pPr/>
             <a:r>
-              <a:t>{{cct}}</a:t>
+              <a:t>{{cct_resumido}}</a:t>
             </a:r>
           </a:p>
         </p:txBody>
@@ -5343,8 +5369,8 @@
         </p:nvSpPr>
         <p:spPr>
           <a:xfrm>
-            <a:off x="5327903" y="3859967"/>
-            <a:ext cx="521655" cy="153611"/>
+            <a:off x="5137417" y="3859967"/>
+            <a:ext cx="829799" cy="153611"/>
           </a:xfrm>
           <a:prstGeom prst="rect">
             <a:avLst/>
@@ -5378,7 +5404,7 @@
           <a:p>
             <a:pPr/>
             <a:r>
-              <a:t>{{ip}}</a:t>
+              <a:t>{{ip_resumido}}</a:t>
             </a:r>
           </a:p>
         </p:txBody>
@@ -5391,8 +5417,8 @@
         </p:nvSpPr>
         <p:spPr>
           <a:xfrm>
-            <a:off x="5966128" y="3871438"/>
-            <a:ext cx="1363256" cy="153611"/>
+            <a:off x="5966128" y="3858738"/>
+            <a:ext cx="1363260" cy="153611"/>
           </a:xfrm>
           <a:prstGeom prst="rect">
             <a:avLst/>
@@ -5488,7 +5514,7 @@
         <p:spPr>
           <a:xfrm>
             <a:off x="1562592" y="3292671"/>
-            <a:ext cx="539769" cy="127001"/>
+            <a:ext cx="539773" cy="127001"/>
           </a:xfrm>
           <a:prstGeom prst="rect">
             <a:avLst/>
@@ -5536,7 +5562,7 @@
         <p:spPr>
           <a:xfrm>
             <a:off x="2901785" y="3294131"/>
-            <a:ext cx="315286" cy="127001"/>
+            <a:ext cx="315290" cy="127001"/>
           </a:xfrm>
           <a:prstGeom prst="rect">
             <a:avLst/>
@@ -5584,7 +5610,7 @@
         <p:spPr>
           <a:xfrm>
             <a:off x="4078668" y="3235659"/>
-            <a:ext cx="582039" cy="173477"/>
+            <a:ext cx="582043" cy="173477"/>
           </a:xfrm>
           <a:prstGeom prst="rect">
             <a:avLst/>
@@ -5632,7 +5658,7 @@
         <p:spPr>
           <a:xfrm>
             <a:off x="5315153" y="3229309"/>
-            <a:ext cx="582039" cy="173477"/>
+            <a:ext cx="582043" cy="173477"/>
           </a:xfrm>
           <a:prstGeom prst="rect">
             <a:avLst/>
@@ -5680,7 +5706,7 @@
         <p:spPr>
           <a:xfrm>
             <a:off x="6324367" y="3280114"/>
-            <a:ext cx="582039" cy="127001"/>
+            <a:ext cx="582043" cy="127001"/>
           </a:xfrm>
           <a:prstGeom prst="rect">
             <a:avLst/>
@@ -5728,7 +5754,7 @@
         <p:spPr>
           <a:xfrm>
             <a:off x="5163563" y="79341"/>
-            <a:ext cx="2230642" cy="133291"/>
+            <a:ext cx="2230646" cy="133291"/>
           </a:xfrm>
           <a:prstGeom prst="rect">
             <a:avLst/>
@@ -5920,7 +5946,7 @@
         <p:spPr>
           <a:xfrm>
             <a:off x="2855895" y="4504602"/>
-            <a:ext cx="1363263" cy="133291"/>
+            <a:ext cx="1363267" cy="133291"/>
           </a:xfrm>
           <a:prstGeom prst="rect">
             <a:avLst/>
@@ -6015,8 +6041,8 @@
         </p:nvSpPr>
         <p:spPr>
           <a:xfrm>
-            <a:off x="1988506" y="4659517"/>
-            <a:ext cx="2230642" cy="133291"/>
+            <a:off x="1988505" y="4659517"/>
+            <a:ext cx="2230643" cy="133291"/>
           </a:xfrm>
           <a:prstGeom prst="rect">
             <a:avLst/>
@@ -6112,7 +6138,7 @@
         <p:spPr>
           <a:xfrm>
             <a:off x="2305635" y="4814432"/>
-            <a:ext cx="1913516" cy="133291"/>
+            <a:ext cx="1913517" cy="133291"/>
           </a:xfrm>
           <a:prstGeom prst="rect">
             <a:avLst/>
@@ -6207,8 +6233,8 @@
         </p:nvSpPr>
         <p:spPr>
           <a:xfrm>
-            <a:off x="1552970" y="4969347"/>
-            <a:ext cx="2666182" cy="133291"/>
+            <a:off x="1552969" y="4969347"/>
+            <a:ext cx="2666187" cy="133291"/>
           </a:xfrm>
           <a:prstGeom prst="rect">
             <a:avLst/>
@@ -6495,8 +6521,8 @@
         </p:nvSpPr>
         <p:spPr>
           <a:xfrm>
-            <a:off x="1552977" y="5429060"/>
-            <a:ext cx="2666168" cy="133291"/>
+            <a:off x="1552976" y="5429060"/>
+            <a:ext cx="2666173" cy="133291"/>
           </a:xfrm>
           <a:prstGeom prst="rect">
             <a:avLst/>
@@ -6880,7 +6906,7 @@
         <p:spPr>
           <a:xfrm>
             <a:off x="3423792" y="6048721"/>
-            <a:ext cx="795366" cy="133291"/>
+            <a:ext cx="795370" cy="133291"/>
           </a:xfrm>
           <a:prstGeom prst="rect">
             <a:avLst/>
@@ -6976,7 +7002,7 @@
         <p:spPr>
           <a:xfrm>
             <a:off x="3423792" y="6203634"/>
-            <a:ext cx="795366" cy="133291"/>
+            <a:ext cx="795370" cy="133291"/>
           </a:xfrm>
           <a:prstGeom prst="rect">
             <a:avLst/>
@@ -7072,7 +7098,7 @@
         <p:spPr>
           <a:xfrm>
             <a:off x="3423792" y="6349024"/>
-            <a:ext cx="795366" cy="133291"/>
+            <a:ext cx="795370" cy="133291"/>
           </a:xfrm>
           <a:prstGeom prst="rect">
             <a:avLst/>
@@ -7168,7 +7194,7 @@
         <p:spPr>
           <a:xfrm>
             <a:off x="2084358" y="6503940"/>
-            <a:ext cx="2134794" cy="133291"/>
+            <a:ext cx="2134798" cy="133291"/>
           </a:xfrm>
           <a:prstGeom prst="rect">
             <a:avLst/>
@@ -7263,8 +7289,8 @@
         </p:nvSpPr>
         <p:spPr>
           <a:xfrm>
-            <a:off x="2674006" y="6658854"/>
-            <a:ext cx="1545139" cy="133291"/>
+            <a:off x="1552978" y="6658854"/>
+            <a:ext cx="2666167" cy="133291"/>
           </a:xfrm>
           <a:prstGeom prst="rect">
             <a:avLst/>
@@ -7359,8 +7385,8 @@
         </p:nvSpPr>
         <p:spPr>
           <a:xfrm>
-            <a:off x="1552979" y="6813770"/>
-            <a:ext cx="2666164" cy="133291"/>
+            <a:off x="1552977" y="6813770"/>
+            <a:ext cx="2666170" cy="133291"/>
           </a:xfrm>
           <a:prstGeom prst="rect">
             <a:avLst/>
@@ -7647,8 +7673,8 @@
         </p:nvSpPr>
         <p:spPr>
           <a:xfrm>
-            <a:off x="2596469" y="7273483"/>
-            <a:ext cx="1622690" cy="133291"/>
+            <a:off x="2596468" y="7273483"/>
+            <a:ext cx="1622695" cy="133291"/>
           </a:xfrm>
           <a:prstGeom prst="rect">
             <a:avLst/>
@@ -7744,7 +7770,7 @@
         <p:spPr>
           <a:xfrm>
             <a:off x="3423792" y="7428396"/>
-            <a:ext cx="795366" cy="133291"/>
+            <a:ext cx="795370" cy="133291"/>
           </a:xfrm>
           <a:prstGeom prst="rect">
             <a:avLst/>
@@ -7840,7 +7866,7 @@
         <p:spPr>
           <a:xfrm>
             <a:off x="3418849" y="7709257"/>
-            <a:ext cx="795366" cy="133291"/>
+            <a:ext cx="795370" cy="133291"/>
           </a:xfrm>
           <a:prstGeom prst="rect">
             <a:avLst/>
@@ -7936,7 +7962,7 @@
         <p:spPr>
           <a:xfrm>
             <a:off x="3418849" y="7988451"/>
-            <a:ext cx="795366" cy="133291"/>
+            <a:ext cx="795370" cy="133291"/>
           </a:xfrm>
           <a:prstGeom prst="rect">
             <a:avLst/>
@@ -8032,7 +8058,7 @@
         <p:spPr>
           <a:xfrm>
             <a:off x="3423792" y="8141699"/>
-            <a:ext cx="795366" cy="133291"/>
+            <a:ext cx="795370" cy="133291"/>
           </a:xfrm>
           <a:prstGeom prst="rect">
             <a:avLst/>
@@ -8272,7 +8298,7 @@
         <p:spPr>
           <a:xfrm>
             <a:off x="5756085" y="9252784"/>
-            <a:ext cx="795366" cy="133291"/>
+            <a:ext cx="795370" cy="133291"/>
           </a:xfrm>
           <a:prstGeom prst="rect">
             <a:avLst/>
@@ -8320,7 +8346,7 @@
         <p:spPr>
           <a:xfrm>
             <a:off x="6315238" y="10424724"/>
-            <a:ext cx="1098292" cy="156302"/>
+            <a:ext cx="1098296" cy="156302"/>
           </a:xfrm>
           <a:prstGeom prst="rect">
             <a:avLst/>
@@ -8497,7 +8523,7 @@
         <p:spPr>
           <a:xfrm>
             <a:off x="583008" y="3413028"/>
-            <a:ext cx="424094" cy="461802"/>
+            <a:ext cx="424094" cy="461806"/>
           </a:xfrm>
           <a:prstGeom prst="rect">
             <a:avLst/>
@@ -8555,7 +8581,7 @@
         <p:spPr>
           <a:xfrm>
             <a:off x="2842939" y="3394678"/>
-            <a:ext cx="446738" cy="481873"/>
+            <a:ext cx="446742" cy="481877"/>
           </a:xfrm>
           <a:prstGeom prst="rect">
             <a:avLst/>
@@ -8584,7 +8610,7 @@
         <p:spPr>
           <a:xfrm>
             <a:off x="4140632" y="3413028"/>
-            <a:ext cx="436704" cy="461802"/>
+            <a:ext cx="436708" cy="461806"/>
           </a:xfrm>
           <a:prstGeom prst="rect">
             <a:avLst/>
@@ -8613,7 +8639,7 @@
         <p:spPr>
           <a:xfrm>
             <a:off x="5362859" y="3405499"/>
-            <a:ext cx="451762" cy="476860"/>
+            <a:ext cx="451766" cy="476864"/>
           </a:xfrm>
           <a:prstGeom prst="rect">
             <a:avLst/>
@@ -8642,7 +8668,7 @@
         <p:spPr>
           <a:xfrm>
             <a:off x="6396387" y="3413028"/>
-            <a:ext cx="451762" cy="461802"/>
+            <a:ext cx="451766" cy="461806"/>
           </a:xfrm>
           <a:prstGeom prst="rect">
             <a:avLst/>
@@ -8671,7 +8697,7 @@
         <p:spPr>
           <a:xfrm>
             <a:off x="605077" y="9721245"/>
-            <a:ext cx="454216" cy="450784"/>
+            <a:ext cx="454216" cy="450788"/>
           </a:xfrm>
           <a:prstGeom prst="rect">
             <a:avLst/>
@@ -8700,7 +8726,7 @@
         <p:spPr>
           <a:xfrm>
             <a:off x="1779010" y="9698676"/>
-            <a:ext cx="457653" cy="461107"/>
+            <a:ext cx="457653" cy="461111"/>
           </a:xfrm>
           <a:prstGeom prst="rect">
             <a:avLst/>
@@ -8729,7 +8755,7 @@
         <p:spPr>
           <a:xfrm>
             <a:off x="2950392" y="9683801"/>
-            <a:ext cx="450768" cy="485194"/>
+            <a:ext cx="450768" cy="485198"/>
           </a:xfrm>
           <a:prstGeom prst="rect">
             <a:avLst/>
@@ -8758,7 +8784,7 @@
         <p:spPr>
           <a:xfrm>
             <a:off x="5292266" y="9680209"/>
-            <a:ext cx="443902" cy="464547"/>
+            <a:ext cx="443906" cy="464551"/>
           </a:xfrm>
           <a:prstGeom prst="rect">
             <a:avLst/>
@@ -8787,7 +8813,7 @@
         <p:spPr>
           <a:xfrm>
             <a:off x="4126064" y="9692909"/>
-            <a:ext cx="450784" cy="447343"/>
+            <a:ext cx="450788" cy="447347"/>
           </a:xfrm>
           <a:prstGeom prst="rect">
             <a:avLst/>
@@ -8816,7 +8842,7 @@
         <p:spPr>
           <a:xfrm>
             <a:off x="6443309" y="9698118"/>
-            <a:ext cx="478311" cy="467989"/>
+            <a:ext cx="478315" cy="467993"/>
           </a:xfrm>
           <a:prstGeom prst="rect">
             <a:avLst/>
@@ -8931,7 +8957,7 @@
         <p:spPr>
           <a:xfrm>
             <a:off x="2628381" y="10182300"/>
-            <a:ext cx="1094799" cy="127001"/>
+            <a:ext cx="1094803" cy="127001"/>
           </a:xfrm>
           <a:prstGeom prst="rect">
             <a:avLst/>
@@ -8979,7 +9005,7 @@
         <p:spPr>
           <a:xfrm>
             <a:off x="3804056" y="10175126"/>
-            <a:ext cx="1094799" cy="127001"/>
+            <a:ext cx="1094803" cy="127001"/>
           </a:xfrm>
           <a:prstGeom prst="rect">
             <a:avLst/>
@@ -9027,7 +9053,7 @@
         <p:spPr>
           <a:xfrm>
             <a:off x="4966818" y="10168408"/>
-            <a:ext cx="1094798" cy="127001"/>
+            <a:ext cx="1094802" cy="127001"/>
           </a:xfrm>
           <a:prstGeom prst="rect">
             <a:avLst/>
@@ -9075,7 +9101,7 @@
         <p:spPr>
           <a:xfrm>
             <a:off x="6135065" y="10168408"/>
-            <a:ext cx="1094798" cy="127001"/>
+            <a:ext cx="1094802" cy="127001"/>
           </a:xfrm>
           <a:prstGeom prst="rect">
             <a:avLst/>
@@ -9123,7 +9149,7 @@
         <p:spPr>
           <a:xfrm>
             <a:off x="5499403" y="6636666"/>
-            <a:ext cx="1909806" cy="1250891"/>
+            <a:ext cx="1909806" cy="1390591"/>
           </a:xfrm>
           <a:prstGeom prst="rect">
             <a:avLst/>
@@ -9249,6 +9275,19 @@
               </a:defRPr>
             </a:pPr>
           </a:p>
+          <a:p>
+            <a:pPr algn="ctr">
+              <a:lnSpc>
+                <a:spcPts val="1100"/>
+              </a:lnSpc>
+              <a:defRPr b="1" sz="800">
+                <a:latin typeface="Arial"/>
+                <a:ea typeface="Arial"/>
+                <a:cs typeface="Arial"/>
+                <a:sym typeface="Arial"/>
+              </a:defRPr>
+            </a:pPr>
+          </a:p>
         </p:txBody>
       </p:sp>
       <p:sp>
@@ -9259,8 +9298,8 @@
         </p:nvSpPr>
         <p:spPr>
           <a:xfrm>
-            <a:off x="183467" y="776907"/>
-            <a:ext cx="2031583" cy="1809692"/>
+            <a:off x="183467" y="776903"/>
+            <a:ext cx="2031583" cy="2089092"/>
           </a:xfrm>
           <a:prstGeom prst="rect">
             <a:avLst/>
@@ -9438,6 +9477,32 @@
               </a:defRPr>
             </a:pPr>
           </a:p>
+          <a:p>
+            <a:pPr algn="ctr">
+              <a:lnSpc>
+                <a:spcPts val="1100"/>
+              </a:lnSpc>
+              <a:defRPr b="1" sz="800">
+                <a:latin typeface="Arial"/>
+                <a:ea typeface="Arial"/>
+                <a:cs typeface="Arial"/>
+                <a:sym typeface="Arial"/>
+              </a:defRPr>
+            </a:pPr>
+          </a:p>
+          <a:p>
+            <a:pPr algn="ctr">
+              <a:lnSpc>
+                <a:spcPts val="1100"/>
+              </a:lnSpc>
+              <a:defRPr b="1" sz="800">
+                <a:latin typeface="Arial"/>
+                <a:ea typeface="Arial"/>
+                <a:cs typeface="Arial"/>
+                <a:sym typeface="Arial"/>
+              </a:defRPr>
+            </a:pPr>
+          </a:p>
         </p:txBody>
       </p:sp>
       <p:sp>
@@ -9638,7 +9703,7 @@
         <p:spPr>
           <a:xfrm>
             <a:off x="5794297" y="8595576"/>
-            <a:ext cx="690377" cy="541626"/>
+            <a:ext cx="690381" cy="681326"/>
           </a:xfrm>
           <a:prstGeom prst="rect">
             <a:avLst/>
@@ -9699,6 +9764,19 @@
               </a:defRPr>
             </a:pPr>
           </a:p>
+          <a:p>
+            <a:pPr algn="ctr">
+              <a:lnSpc>
+                <a:spcPts val="1100"/>
+              </a:lnSpc>
+              <a:defRPr b="1" sz="400">
+                <a:latin typeface="Arial"/>
+                <a:ea typeface="Arial"/>
+                <a:cs typeface="Arial"/>
+                <a:sym typeface="Arial"/>
+              </a:defRPr>
+            </a:pPr>
+          </a:p>
         </p:txBody>
       </p:sp>
       <p:sp>
@@ -9709,8 +9787,8 @@
         </p:nvSpPr>
         <p:spPr>
           <a:xfrm>
-            <a:off x="4461940" y="8079823"/>
-            <a:ext cx="2964409" cy="133291"/>
+            <a:off x="4461938" y="8079823"/>
+            <a:ext cx="2964414" cy="133291"/>
           </a:xfrm>
           <a:prstGeom prst="rect">
             <a:avLst/>
@@ -9758,7 +9836,7 @@
         <p:spPr>
           <a:xfrm>
             <a:off x="4461940" y="6784526"/>
-            <a:ext cx="1098292" cy="272991"/>
+            <a:ext cx="1098296" cy="272991"/>
           </a:xfrm>
           <a:prstGeom prst="rect">
             <a:avLst/>

</xml_diff>